<commit_message>
Connection engagement package: delivery artifacts, role/phase execution navigator, static upload library
</commit_message>
<xml_diff>
--- a/03_Shared/05_Workshop_Presentations/ECS_CMDB_Workshop_Modernizing_the_Core.pptx
+++ b/03_Shared/05_Workshop_Presentations/ECS_CMDB_Workshop_Modernizing_the_Core.pptx
@@ -12952,6 +12952,10 @@
             <a:prstDash val="solid"/>
           </a:ln>
         </p:spPr>
+        <p:txBody>
+          <a:bodyPr/>
+          <a:p/>
+        </p:txBody>
       </p:sp>
       <p:sp>
         <p:nvSpPr>
@@ -13122,6 +13126,10 @@
             <a:prstDash val="solid"/>
           </a:ln>
         </p:spPr>
+        <p:txBody>
+          <a:bodyPr/>
+          <a:p/>
+        </p:txBody>
       </p:sp>
       <p:sp>
         <p:nvSpPr>
@@ -13147,6 +13155,10 @@
             <a:prstDash val="solid"/>
           </a:ln>
         </p:spPr>
+        <p:txBody>
+          <a:bodyPr/>
+          <a:p/>
+        </p:txBody>
       </p:sp>
       <p:sp>
         <p:nvSpPr>
@@ -13208,6 +13220,10 @@
             <a:prstDash val="solid"/>
           </a:ln>
         </p:spPr>
+        <p:txBody>
+          <a:bodyPr/>
+          <a:p/>
+        </p:txBody>
       </p:sp>
       <p:sp>
         <p:nvSpPr>
@@ -13230,140 +13246,204 @@
           <a:bodyPr wrap="square" rtlCol="0" anchor="t"/>
           <a:lstStyle/>
           <a:p>
-            <a:pPr indent="0" marL="0">
-              <a:buNone/>
-            </a:pPr>
-            <a:r>
-              <a:rPr lang="en-US" sz="1100" dirty="0">
-                <a:solidFill>
-                  <a:srgbClr val="334155"/>
-                </a:solidFill>
-                <a:latin typeface="Calibri" pitchFamily="34" charset="0"/>
-                <a:ea typeface="Calibri" pitchFamily="34" charset="-122"/>
-                <a:cs typeface="Calibri" pitchFamily="34" charset="-120"/>
-              </a:rPr>
-              <a:t>✓  Activating and configuring OOTB features</a:t>
-            </a:r>
-            <a:endParaRPr lang="en-US" sz="1100" dirty="0"/>
-          </a:p>
-          <a:p>
-            <a:pPr indent="0" marL="0">
-              <a:buNone/>
-            </a:pPr>
-            <a:r>
-              <a:rPr lang="en-US" sz="1100" dirty="0">
-                <a:solidFill>
-                  <a:srgbClr val="334155"/>
-                </a:solidFill>
-                <a:latin typeface="Calibri" pitchFamily="34" charset="0"/>
-                <a:ea typeface="Calibri" pitchFamily="34" charset="-122"/>
-                <a:cs typeface="Calibri" pitchFamily="34" charset="-120"/>
-              </a:rPr>
-              <a:t>✓  Setting up categories and taxonomies</a:t>
-            </a:r>
-            <a:endParaRPr lang="en-US" sz="1100" dirty="0"/>
-          </a:p>
-          <a:p>
-            <a:pPr indent="0" marL="0">
-              <a:buNone/>
-            </a:pPr>
-            <a:r>
-              <a:rPr lang="en-US" sz="1100" dirty="0">
-                <a:solidFill>
-                  <a:srgbClr val="334155"/>
-                </a:solidFill>
-                <a:latin typeface="Calibri" pitchFamily="34" charset="0"/>
-                <a:ea typeface="Calibri" pitchFamily="34" charset="-122"/>
-                <a:cs typeface="Calibri" pitchFamily="34" charset="-120"/>
-              </a:rPr>
-              <a:t>✓  Building assignment rules and routing logic</a:t>
-            </a:r>
-            <a:endParaRPr lang="en-US" sz="1100" dirty="0"/>
-          </a:p>
-          <a:p>
-            <a:pPr indent="0" marL="0">
-              <a:buNone/>
-            </a:pPr>
-            <a:r>
-              <a:rPr lang="en-US" sz="1100" dirty="0">
-                <a:solidFill>
-                  <a:srgbClr val="334155"/>
-                </a:solidFill>
-                <a:latin typeface="Calibri" pitchFamily="34" charset="0"/>
-                <a:ea typeface="Calibri" pitchFamily="34" charset="-122"/>
-                <a:cs typeface="Calibri" pitchFamily="34" charset="-120"/>
-              </a:rPr>
-              <a:t>✓  Defining SLA targets and schedules</a:t>
-            </a:r>
-            <a:endParaRPr lang="en-US" sz="1100" dirty="0"/>
-          </a:p>
-          <a:p>
-            <a:pPr indent="0" marL="0">
-              <a:buNone/>
-            </a:pPr>
-            <a:r>
-              <a:rPr lang="en-US" sz="1100" dirty="0">
-                <a:solidFill>
-                  <a:srgbClr val="334155"/>
-                </a:solidFill>
-                <a:latin typeface="Calibri" pitchFamily="34" charset="0"/>
-                <a:ea typeface="Calibri" pitchFamily="34" charset="-122"/>
-                <a:cs typeface="Calibri" pitchFamily="34" charset="-120"/>
-              </a:rPr>
-              <a:t>✓  Configuring notifications and email templates</a:t>
-            </a:r>
-            <a:endParaRPr lang="en-US" sz="1100" dirty="0"/>
-          </a:p>
-          <a:p>
-            <a:pPr indent="0" marL="0">
-              <a:buNone/>
-            </a:pPr>
-            <a:r>
-              <a:rPr lang="en-US" sz="1100" dirty="0">
-                <a:solidFill>
-                  <a:srgbClr val="334155"/>
-                </a:solidFill>
-                <a:latin typeface="Calibri" pitchFamily="34" charset="0"/>
-                <a:ea typeface="Calibri" pitchFamily="34" charset="-122"/>
-                <a:cs typeface="Calibri" pitchFamily="34" charset="-120"/>
-              </a:rPr>
-              <a:t>✓  Enabling AI features (PI, Now Assist, Virtual Agent)</a:t>
-            </a:r>
-            <a:endParaRPr lang="en-US" sz="1100" dirty="0"/>
-          </a:p>
-          <a:p>
-            <a:pPr indent="0" marL="0">
-              <a:buNone/>
-            </a:pPr>
-            <a:r>
-              <a:rPr lang="en-US" sz="1100" dirty="0">
-                <a:solidFill>
-                  <a:srgbClr val="334155"/>
-                </a:solidFill>
-                <a:latin typeface="Calibri" pitchFamily="34" charset="0"/>
-                <a:ea typeface="Calibri" pitchFamily="34" charset="-122"/>
-                <a:cs typeface="Calibri" pitchFamily="34" charset="-120"/>
-              </a:rPr>
-              <a:t>✓  Building reports and PA indicators</a:t>
-            </a:r>
-            <a:endParaRPr lang="en-US" sz="1100" dirty="0"/>
-          </a:p>
-          <a:p>
-            <a:pPr indent="0" marL="0">
-              <a:buNone/>
-            </a:pPr>
-            <a:r>
-              <a:rPr lang="en-US" sz="1100" dirty="0">
-                <a:solidFill>
-                  <a:srgbClr val="334155"/>
-                </a:solidFill>
-                <a:latin typeface="Calibri" pitchFamily="34" charset="0"/>
-                <a:ea typeface="Calibri" pitchFamily="34" charset="-122"/>
-                <a:cs typeface="Calibri" pitchFamily="34" charset="-120"/>
-              </a:rPr>
-              <a:t>✓  Setting system properties and thresholds</a:t>
-            </a:r>
-            <a:endParaRPr lang="en-US" sz="1100" dirty="0"/>
+            <a:r>
+              <a:rPr lang="en-US" dirty="0" sz="1100">
+                <a:solidFill>
+                  <a:srgbClr val="16A34A"/>
+                </a:solidFill>
+                <a:latin typeface="Calibri"/>
+              </a:rPr>
+              <a:t>✓  </a:t>
+            </a:r>
+            <a:r>
+              <a:rPr lang="en-US" dirty="0" sz="1100">
+                <a:solidFill>
+                  <a:srgbClr val="1A1A1A"/>
+                </a:solidFill>
+                <a:latin typeface="Calibri"/>
+              </a:rPr>
+              <a:t>Defining in-scope CI classes in CMDB Studio (Server, Database, Network Device, Application, Virtual Machine)</a:t>
+            </a:r>
+          </a:p>
+          <a:p>
+            <a:r>
+              <a:rPr lang="en-US" dirty="0" sz="1100">
+                <a:solidFill>
+                  <a:srgbClr val="16A34A"/>
+                </a:solidFill>
+                <a:latin typeface="Calibri"/>
+              </a:rPr>
+              <a:t>✓  </a:t>
+            </a:r>
+            <a:r>
+              <a:rPr lang="en-US" dirty="0" sz="1100">
+                <a:solidFill>
+                  <a:srgbClr val="1A1A1A"/>
+                </a:solidFill>
+                <a:latin typeface="Calibri"/>
+              </a:rPr>
+              <a:t>Configuring OOTB CI relationship types (Runs on, Depends on, Virtualized by, Hosted on)</a:t>
+            </a:r>
+          </a:p>
+          <a:p>
+            <a:r>
+              <a:rPr lang="en-US" dirty="0" sz="1100">
+                <a:solidFill>
+                  <a:srgbClr val="16A34A"/>
+                </a:solidFill>
+                <a:latin typeface="Calibri"/>
+              </a:rPr>
+              <a:t>✓  </a:t>
+            </a:r>
+            <a:r>
+              <a:rPr lang="en-US" dirty="0" sz="1100">
+                <a:solidFill>
+                  <a:srgbClr val="1A1A1A"/>
+                </a:solidFill>
+                <a:latin typeface="Calibri"/>
+              </a:rPr>
+              <a:t>Setting CMDB Health thresholds (completeness %, staleness days, compliance rules)</a:t>
+            </a:r>
+          </a:p>
+          <a:p>
+            <a:r>
+              <a:rPr lang="en-US" dirty="0" sz="1100">
+                <a:solidFill>
+                  <a:srgbClr val="16A34A"/>
+                </a:solidFill>
+                <a:latin typeface="Calibri"/>
+              </a:rPr>
+              <a:t>✓  </a:t>
+            </a:r>
+            <a:r>
+              <a:rPr lang="en-US" dirty="0" sz="1100">
+                <a:solidFill>
+                  <a:srgbClr val="1A1A1A"/>
+                </a:solidFill>
+                <a:latin typeface="Calibri"/>
+              </a:rPr>
+              <a:t>Configuring Discovery patterns for Windows, Linux, VMware, network devices (OOTB patterns)</a:t>
+            </a:r>
+          </a:p>
+          <a:p>
+            <a:r>
+              <a:rPr lang="en-US" dirty="0" sz="1100">
+                <a:solidFill>
+                  <a:srgbClr val="16A34A"/>
+                </a:solidFill>
+                <a:latin typeface="Calibri"/>
+              </a:rPr>
+              <a:t>✓  </a:t>
+            </a:r>
+            <a:r>
+              <a:rPr lang="en-US" dirty="0" sz="1100">
+                <a:solidFill>
+                  <a:srgbClr val="1A1A1A"/>
+                </a:solidFill>
+                <a:latin typeface="Calibri"/>
+              </a:rPr>
+              <a:t>Setting normalization rules for hardware and software product names</a:t>
+            </a:r>
+          </a:p>
+          <a:p>
+            <a:r>
+              <a:rPr lang="en-US" dirty="0" sz="1100">
+                <a:solidFill>
+                  <a:srgbClr val="16A34A"/>
+                </a:solidFill>
+                <a:latin typeface="Calibri"/>
+              </a:rPr>
+              <a:t>✓  </a:t>
+            </a:r>
+            <a:r>
+              <a:rPr lang="en-US" dirty="0" sz="1100">
+                <a:solidFill>
+                  <a:srgbClr val="1A1A1A"/>
+                </a:solidFill>
+                <a:latin typeface="Calibri"/>
+              </a:rPr>
+              <a:t>Configuring CI lifecycle states (Installed, In Maintenance, Retired)</a:t>
+            </a:r>
+          </a:p>
+          <a:p>
+            <a:r>
+              <a:rPr lang="en-US" dirty="0" sz="1100">
+                <a:solidFill>
+                  <a:srgbClr val="16A34A"/>
+                </a:solidFill>
+                <a:latin typeface="Calibri"/>
+              </a:rPr>
+              <a:t>✓  </a:t>
+            </a:r>
+            <a:r>
+              <a:rPr lang="en-US" dirty="0" sz="1100">
+                <a:solidFill>
+                  <a:srgbClr val="1A1A1A"/>
+                </a:solidFill>
+                <a:latin typeface="Calibri"/>
+              </a:rPr>
+              <a:t>Defining CI ownership and stewardship roles via OOTB CI record fields</a:t>
+            </a:r>
+          </a:p>
+          <a:p>
+            <a:r>
+              <a:rPr lang="en-US" dirty="0" sz="1100">
+                <a:solidFill>
+                  <a:srgbClr val="16A34A"/>
+                </a:solidFill>
+                <a:latin typeface="Calibri"/>
+              </a:rPr>
+              <a:t>✓  </a:t>
+            </a:r>
+            <a:r>
+              <a:rPr lang="en-US" dirty="0" sz="1100">
+                <a:solidFill>
+                  <a:srgbClr val="1A1A1A"/>
+                </a:solidFill>
+                <a:latin typeface="Calibri"/>
+              </a:rPr>
+              <a:t>Setting up CMDB reconciliation rules for Discovery vs. SGC data sources</a:t>
+            </a:r>
+          </a:p>
+          <a:p>
+            <a:r>
+              <a:rPr lang="en-US" dirty="0" sz="1100">
+                <a:solidFill>
+                  <a:srgbClr val="16A34A"/>
+                </a:solidFill>
+                <a:latin typeface="Calibri"/>
+              </a:rPr>
+              <a:t>✓  </a:t>
+            </a:r>
+            <a:r>
+              <a:rPr lang="en-US" dirty="0" sz="1100">
+                <a:solidFill>
+                  <a:srgbClr val="1A1A1A"/>
+                </a:solidFill>
+                <a:latin typeface="Calibri"/>
+              </a:rPr>
+              <a:t>Configuring CI class-specific mandatory attributes via CMDB Studio</a:t>
+            </a:r>
+          </a:p>
+          <a:p>
+            <a:r>
+              <a:rPr lang="en-US" dirty="0" sz="1100">
+                <a:solidFill>
+                  <a:srgbClr val="16A34A"/>
+                </a:solidFill>
+                <a:latin typeface="Calibri"/>
+              </a:rPr>
+              <a:t>✓  </a:t>
+            </a:r>
+            <a:r>
+              <a:rPr lang="en-US" dirty="0" sz="1100">
+                <a:solidFill>
+                  <a:srgbClr val="1A1A1A"/>
+                </a:solidFill>
+                <a:latin typeface="Calibri"/>
+              </a:rPr>
+              <a:t>Enabling OOTB CMDB Health dashboard and compliance scoring</a:t>
+            </a:r>
           </a:p>
         </p:txBody>
       </p:sp>
@@ -13391,6 +13471,10 @@
             <a:prstDash val="solid"/>
           </a:ln>
         </p:spPr>
+        <p:txBody>
+          <a:bodyPr/>
+          <a:p/>
+        </p:txBody>
       </p:sp>
       <p:sp>
         <p:nvSpPr>
@@ -13452,6 +13536,10 @@
             <a:prstDash val="solid"/>
           </a:ln>
         </p:spPr>
+        <p:txBody>
+          <a:bodyPr/>
+          <a:p/>
+        </p:txBody>
       </p:sp>
       <p:sp>
         <p:nvSpPr>
@@ -13474,106 +13562,204 @@
           <a:bodyPr wrap="square" rtlCol="0" anchor="t"/>
           <a:lstStyle/>
           <a:p>
-            <a:pPr indent="0" marL="0">
-              <a:buNone/>
-            </a:pPr>
-            <a:r>
-              <a:rPr lang="en-US" sz="1100" dirty="0">
-                <a:solidFill>
-                  <a:srgbClr val="334155"/>
-                </a:solidFill>
-                <a:latin typeface="Calibri" pitchFamily="34" charset="0"/>
-                <a:ea typeface="Calibri" pitchFamily="34" charset="-122"/>
-                <a:cs typeface="Calibri" pitchFamily="34" charset="-120"/>
-              </a:rPr>
-              <a:t>✗  Adding new fields to OOTB tables</a:t>
-            </a:r>
-            <a:endParaRPr lang="en-US" sz="1100" dirty="0"/>
-          </a:p>
-          <a:p>
-            <a:pPr indent="0" marL="0">
-              <a:buNone/>
-            </a:pPr>
-            <a:r>
-              <a:rPr lang="en-US" sz="1100" dirty="0">
-                <a:solidFill>
-                  <a:srgbClr val="334155"/>
-                </a:solidFill>
-                <a:latin typeface="Calibri" pitchFamily="34" charset="0"/>
-                <a:ea typeface="Calibri" pitchFamily="34" charset="-122"/>
-                <a:cs typeface="Calibri" pitchFamily="34" charset="-120"/>
-              </a:rPr>
-              <a:t>✗  Writing custom business rules or script actions</a:t>
-            </a:r>
-            <a:endParaRPr lang="en-US" sz="1100" dirty="0"/>
-          </a:p>
-          <a:p>
-            <a:pPr indent="0" marL="0">
-              <a:buNone/>
-            </a:pPr>
-            <a:r>
-              <a:rPr lang="en-US" sz="1100" dirty="0">
-                <a:solidFill>
-                  <a:srgbClr val="334155"/>
-                </a:solidFill>
-                <a:latin typeface="Calibri" pitchFamily="34" charset="0"/>
-                <a:ea typeface="Calibri" pitchFamily="34" charset="-122"/>
-                <a:cs typeface="Calibri" pitchFamily="34" charset="-120"/>
-              </a:rPr>
-              <a:t>✗  Creating non-standard CI classes or table extensions</a:t>
-            </a:r>
-            <a:endParaRPr lang="en-US" sz="1100" dirty="0"/>
-          </a:p>
-          <a:p>
-            <a:pPr indent="0" marL="0">
-              <a:buNone/>
-            </a:pPr>
-            <a:r>
-              <a:rPr lang="en-US" sz="1100" dirty="0">
-                <a:solidFill>
-                  <a:srgbClr val="334155"/>
-                </a:solidFill>
-                <a:latin typeface="Calibri" pitchFamily="34" charset="0"/>
-                <a:ea typeface="Calibri" pitchFamily="34" charset="-122"/>
-                <a:cs typeface="Calibri" pitchFamily="34" charset="-120"/>
-              </a:rPr>
-              <a:t>✗  Modifying OOTB workflow stages in code</a:t>
-            </a:r>
-            <a:endParaRPr lang="en-US" sz="1100" dirty="0"/>
-          </a:p>
-          <a:p>
-            <a:pPr indent="0" marL="0">
-              <a:buNone/>
-            </a:pPr>
-            <a:r>
-              <a:rPr lang="en-US" sz="1100" dirty="0">
-                <a:solidFill>
-                  <a:srgbClr val="334155"/>
-                </a:solidFill>
-                <a:latin typeface="Calibri" pitchFamily="34" charset="0"/>
-                <a:ea typeface="Calibri" pitchFamily="34" charset="-122"/>
-                <a:cs typeface="Calibri" pitchFamily="34" charset="-120"/>
-              </a:rPr>
-              <a:t>✗  Building custom client scripts or UI policies</a:t>
-            </a:r>
-            <a:endParaRPr lang="en-US" sz="1100" dirty="0"/>
-          </a:p>
-          <a:p>
-            <a:pPr indent="0" marL="0">
-              <a:buNone/>
-            </a:pPr>
-            <a:r>
-              <a:rPr lang="en-US" sz="1100" dirty="0">
-                <a:solidFill>
-                  <a:srgbClr val="334155"/>
-                </a:solidFill>
-                <a:latin typeface="Calibri" pitchFamily="34" charset="0"/>
-                <a:ea typeface="Calibri" pitchFamily="34" charset="-122"/>
-                <a:cs typeface="Calibri" pitchFamily="34" charset="-120"/>
-              </a:rPr>
-              <a:t>✗  Creating custom REST endpoints outside the catalog</a:t>
-            </a:r>
-            <a:endParaRPr lang="en-US" sz="1100" dirty="0"/>
+            <a:r>
+              <a:rPr lang="en-US" dirty="0" sz="1100">
+                <a:solidFill>
+                  <a:srgbClr val="B91C1C"/>
+                </a:solidFill>
+                <a:latin typeface="Calibri"/>
+              </a:rPr>
+              <a:t>✗  </a:t>
+            </a:r>
+            <a:r>
+              <a:rPr lang="en-US" dirty="0" sz="1100">
+                <a:solidFill>
+                  <a:srgbClr val="1A1A1A"/>
+                </a:solidFill>
+                <a:latin typeface="Calibri"/>
+              </a:rPr>
+              <a:t>Custom CI class tables outside the OOTB cmdb_ci hierarchy</a:t>
+            </a:r>
+          </a:p>
+          <a:p>
+            <a:r>
+              <a:rPr lang="en-US" dirty="0" sz="1100">
+                <a:solidFill>
+                  <a:srgbClr val="B91C1C"/>
+                </a:solidFill>
+                <a:latin typeface="Calibri"/>
+              </a:rPr>
+              <a:t>✗  </a:t>
+            </a:r>
+            <a:r>
+              <a:rPr lang="en-US" dirty="0" sz="1100">
+                <a:solidFill>
+                  <a:srgbClr val="1A1A1A"/>
+                </a:solidFill>
+                <a:latin typeface="Calibri"/>
+              </a:rPr>
+              <a:t>Scripted CI relationship population from external data sources</a:t>
+            </a:r>
+          </a:p>
+          <a:p>
+            <a:r>
+              <a:rPr lang="en-US" dirty="0" sz="1100">
+                <a:solidFill>
+                  <a:srgbClr val="B91C1C"/>
+                </a:solidFill>
+                <a:latin typeface="Calibri"/>
+              </a:rPr>
+              <a:t>✗  </a:t>
+            </a:r>
+            <a:r>
+              <a:rPr lang="en-US" dirty="0" sz="1100">
+                <a:solidFill>
+                  <a:srgbClr val="1A1A1A"/>
+                </a:solidFill>
+                <a:latin typeface="Calibri"/>
+              </a:rPr>
+              <a:t>Custom CMDB sync logic overriding OOTB Discovery reconciliation</a:t>
+            </a:r>
+          </a:p>
+          <a:p>
+            <a:r>
+              <a:rPr lang="en-US" dirty="0" sz="1100">
+                <a:solidFill>
+                  <a:srgbClr val="B91C1C"/>
+                </a:solidFill>
+                <a:latin typeface="Calibri"/>
+              </a:rPr>
+              <a:t>✗  </a:t>
+            </a:r>
+            <a:r>
+              <a:rPr lang="en-US" dirty="0" sz="1100">
+                <a:solidFill>
+                  <a:srgbClr val="1A1A1A"/>
+                </a:solidFill>
+                <a:latin typeface="Calibri"/>
+              </a:rPr>
+              <a:t>Non-OOTB identification and reconciliation rules (IRE)</a:t>
+            </a:r>
+          </a:p>
+          <a:p>
+            <a:r>
+              <a:rPr lang="en-US" dirty="0" sz="1100">
+                <a:solidFill>
+                  <a:srgbClr val="B91C1C"/>
+                </a:solidFill>
+                <a:latin typeface="Calibri"/>
+              </a:rPr>
+              <a:t>✗  </a:t>
+            </a:r>
+            <a:r>
+              <a:rPr lang="en-US" dirty="0" sz="1100">
+                <a:solidFill>
+                  <a:srgbClr val="1A1A1A"/>
+                </a:solidFill>
+                <a:latin typeface="Calibri"/>
+              </a:rPr>
+              <a:t>Scripted CI health calculations beyond OOTB CMDB Health scoring</a:t>
+            </a:r>
+          </a:p>
+          <a:p>
+            <a:r>
+              <a:rPr lang="en-US" dirty="0" sz="1100">
+                <a:solidFill>
+                  <a:srgbClr val="B91C1C"/>
+                </a:solidFill>
+                <a:latin typeface="Calibri"/>
+              </a:rPr>
+              <a:t>✗  </a:t>
+            </a:r>
+            <a:r>
+              <a:rPr lang="en-US" dirty="0" sz="1100">
+                <a:solidFill>
+                  <a:srgbClr val="1A1A1A"/>
+                </a:solidFill>
+                <a:latin typeface="Calibri"/>
+              </a:rPr>
+              <a:t>Custom CI decommission workflows beyond OOTB lifecycle management</a:t>
+            </a:r>
+          </a:p>
+          <a:p>
+            <a:r>
+              <a:rPr lang="en-US" dirty="0" sz="1100">
+                <a:solidFill>
+                  <a:srgbClr val="B91C1C"/>
+                </a:solidFill>
+                <a:latin typeface="Calibri"/>
+              </a:rPr>
+              <a:t>✗  </a:t>
+            </a:r>
+            <a:r>
+              <a:rPr lang="en-US" dirty="0" sz="1100">
+                <a:solidFill>
+                  <a:srgbClr val="1A1A1A"/>
+                </a:solidFill>
+                <a:latin typeface="Calibri"/>
+              </a:rPr>
+              <a:t>External CMDB data sync overriding OOTB Discovery-sourced CIs</a:t>
+            </a:r>
+          </a:p>
+          <a:p>
+            <a:r>
+              <a:rPr lang="en-US" dirty="0" sz="1100">
+                <a:solidFill>
+                  <a:srgbClr val="B91C1C"/>
+                </a:solidFill>
+                <a:latin typeface="Calibri"/>
+              </a:rPr>
+              <a:t>✗  </a:t>
+            </a:r>
+            <a:r>
+              <a:rPr lang="en-US" dirty="0" sz="1100">
+                <a:solidFill>
+                  <a:srgbClr val="1A1A1A"/>
+                </a:solidFill>
+                <a:latin typeface="Calibri"/>
+              </a:rPr>
+              <a:t>Scripted asset-to-CI linking beyond OOTB HAM/CMDB integration</a:t>
+            </a:r>
+          </a:p>
+          <a:p>
+            <a:r>
+              <a:rPr lang="en-US" dirty="0" sz="1100">
+                <a:solidFill>
+                  <a:srgbClr val="B91C1C"/>
+                </a:solidFill>
+                <a:latin typeface="Calibri"/>
+              </a:rPr>
+              <a:t>✗  </a:t>
+            </a:r>
+            <a:r>
+              <a:rPr lang="en-US" dirty="0" sz="1100">
+                <a:solidFill>
+                  <a:srgbClr val="1A1A1A"/>
+                </a:solidFill>
+                <a:latin typeface="Calibri"/>
+              </a:rPr>
+              <a:t>Custom CMDB dashboard widgets beyond OOTB Health Dashboard</a:t>
+            </a:r>
+          </a:p>
+          <a:p>
+            <a:r>
+              <a:rPr lang="en-US" dirty="0" sz="1100">
+                <a:solidFill>
+                  <a:srgbClr val="B91C1C"/>
+                </a:solidFill>
+                <a:latin typeface="Calibri"/>
+              </a:rPr>
+              <a:t>✗  </a:t>
+            </a:r>
+            <a:r>
+              <a:rPr lang="en-US" dirty="0" sz="1100">
+                <a:solidFill>
+                  <a:srgbClr val="1A1A1A"/>
+                </a:solidFill>
+                <a:latin typeface="Calibri"/>
+              </a:rPr>
+              <a:t>Non-standard CI attribute sets outside OOTB class definitions</a:t>
+            </a:r>
           </a:p>
         </p:txBody>
       </p:sp>
@@ -13601,6 +13787,10 @@
             <a:prstDash val="solid"/>
           </a:ln>
         </p:spPr>
+        <p:txBody>
+          <a:bodyPr/>
+          <a:p/>
+        </p:txBody>
       </p:sp>
       <p:sp>
         <p:nvSpPr>

</xml_diff>